<commit_message>
Mise à jour mémoire : corrections et enrichissements chapitres 2-5
- Corrige le total de variables (16 → 18 : 15 originales + 3 nouvelles)
- Chapitre 2 : formule dataset final $15+3=18$, explication non-linéaire (Spearman, MI, scatter plots)
- Chapitre 3 : liste 16 features régression contextualisée dans les 18 totales, explication random_state=42, R²/RMSE, SMOTE, AUC paradox
- Chapitre 4 : Davies-Bouldin (formule + interprétation), forme rectangulaire clusters ACP (bmi_cat/hypertension), guide lecture SHAP
- Chapitre 5 : sous-section plus-value pipeline diagnostic, sous-section limites corrélations non-linéaires
- Recompilation PDF mémoire

Co-Authored-By: Claude Sonnet 4.6 <noreply@anthropic.com>
</commit_message>
<xml_diff>
--- a/Support Mahamat - Memoire.pptx
+++ b/Support Mahamat - Memoire.pptx
@@ -236,7 +236,7 @@
           <a:p>
             <a:fld id="{C015CFFD-7A3B-8F44-AAAC-392B94A3DBD8}" type="datetimeFigureOut">
               <a:rPr lang="fr-FR" smtClean="0"/>
-              <a:t>07/06/2026</a:t>
+              <a:t>08/06/2026</a:t>
             </a:fld>
             <a:endParaRPr lang="fr-FR"/>
           </a:p>
@@ -1039,7 +1039,7 @@
           <a:p>
             <a:fld id="{5BCAD085-E8A6-8845-BD4E-CB4CCA059FC4}" type="datetimeFigureOut">
               <a:rPr lang="en-US" smtClean="0"/>
-              <a:t>6/7/26</a:t>
+              <a:t>6/8/26</a:t>
             </a:fld>
             <a:endParaRPr lang="en-US"/>
           </a:p>
@@ -1207,7 +1207,7 @@
           <a:p>
             <a:fld id="{5BCAD085-E8A6-8845-BD4E-CB4CCA059FC4}" type="datetimeFigureOut">
               <a:rPr lang="en-US" smtClean="0"/>
-              <a:t>6/7/26</a:t>
+              <a:t>6/8/26</a:t>
             </a:fld>
             <a:endParaRPr lang="en-US"/>
           </a:p>
@@ -1385,7 +1385,7 @@
           <a:p>
             <a:fld id="{5BCAD085-E8A6-8845-BD4E-CB4CCA059FC4}" type="datetimeFigureOut">
               <a:rPr lang="en-US" smtClean="0"/>
-              <a:t>6/7/26</a:t>
+              <a:t>6/8/26</a:t>
             </a:fld>
             <a:endParaRPr lang="en-US"/>
           </a:p>
@@ -1553,7 +1553,7 @@
           <a:p>
             <a:fld id="{5BCAD085-E8A6-8845-BD4E-CB4CCA059FC4}" type="datetimeFigureOut">
               <a:rPr lang="en-US" smtClean="0"/>
-              <a:t>6/7/26</a:t>
+              <a:t>6/8/26</a:t>
             </a:fld>
             <a:endParaRPr lang="en-US"/>
           </a:p>
@@ -1798,7 +1798,7 @@
           <a:p>
             <a:fld id="{5BCAD085-E8A6-8845-BD4E-CB4CCA059FC4}" type="datetimeFigureOut">
               <a:rPr lang="en-US" smtClean="0"/>
-              <a:t>6/7/26</a:t>
+              <a:t>6/8/26</a:t>
             </a:fld>
             <a:endParaRPr lang="en-US"/>
           </a:p>
@@ -2083,7 +2083,7 @@
           <a:p>
             <a:fld id="{5BCAD085-E8A6-8845-BD4E-CB4CCA059FC4}" type="datetimeFigureOut">
               <a:rPr lang="en-US" smtClean="0"/>
-              <a:t>6/7/26</a:t>
+              <a:t>6/8/26</a:t>
             </a:fld>
             <a:endParaRPr lang="en-US"/>
           </a:p>
@@ -2502,7 +2502,7 @@
           <a:p>
             <a:fld id="{5BCAD085-E8A6-8845-BD4E-CB4CCA059FC4}" type="datetimeFigureOut">
               <a:rPr lang="en-US" smtClean="0"/>
-              <a:t>6/7/26</a:t>
+              <a:t>6/8/26</a:t>
             </a:fld>
             <a:endParaRPr lang="en-US"/>
           </a:p>
@@ -2619,7 +2619,7 @@
           <a:p>
             <a:fld id="{5BCAD085-E8A6-8845-BD4E-CB4CCA059FC4}" type="datetimeFigureOut">
               <a:rPr lang="en-US" smtClean="0"/>
-              <a:t>6/7/26</a:t>
+              <a:t>6/8/26</a:t>
             </a:fld>
             <a:endParaRPr lang="en-US"/>
           </a:p>
@@ -2714,7 +2714,7 @@
           <a:p>
             <a:fld id="{5BCAD085-E8A6-8845-BD4E-CB4CCA059FC4}" type="datetimeFigureOut">
               <a:rPr lang="en-US" smtClean="0"/>
-              <a:t>6/7/26</a:t>
+              <a:t>6/8/26</a:t>
             </a:fld>
             <a:endParaRPr lang="en-US"/>
           </a:p>
@@ -2989,7 +2989,7 @@
           <a:p>
             <a:fld id="{5BCAD085-E8A6-8845-BD4E-CB4CCA059FC4}" type="datetimeFigureOut">
               <a:rPr lang="en-US" smtClean="0"/>
-              <a:t>6/7/26</a:t>
+              <a:t>6/8/26</a:t>
             </a:fld>
             <a:endParaRPr lang="en-US"/>
           </a:p>
@@ -3241,7 +3241,7 @@
           <a:p>
             <a:fld id="{5BCAD085-E8A6-8845-BD4E-CB4CCA059FC4}" type="datetimeFigureOut">
               <a:rPr lang="en-US" smtClean="0"/>
-              <a:t>6/7/26</a:t>
+              <a:t>6/8/26</a:t>
             </a:fld>
             <a:endParaRPr lang="en-US"/>
           </a:p>
@@ -3452,7 +3452,7 @@
           <a:p>
             <a:fld id="{5BCAD085-E8A6-8845-BD4E-CB4CCA059FC4}" type="datetimeFigureOut">
               <a:rPr lang="en-US" smtClean="0"/>
-              <a:t>6/7/26</a:t>
+              <a:t>6/8/26</a:t>
             </a:fld>
             <a:endParaRPr lang="en-US"/>
           </a:p>
@@ -9673,7 +9673,7 @@
         <p:spPr>
           <a:xfrm>
             <a:off x="5081653" y="1872228"/>
-            <a:ext cx="5623560" cy="276999"/>
+            <a:ext cx="6294908" cy="276999"/>
           </a:xfrm>
           <a:prstGeom prst="rect">
             <a:avLst/>
@@ -9693,16 +9693,29 @@
                   <a:srgbClr val="505050"/>
                 </a:solidFill>
               </a:rPr>
-              <a:t>Variable temporaire, dérivée de la variable cible, créée pour le clustering</a:t>
+              <a:t>Variable temporaire, pour démontrer l'effet du data </a:t>
+            </a:r>
+            <a:r>
+              <a:rPr lang="fr-FR" sz="1200" i="1" dirty="0" err="1">
+                <a:solidFill>
+                  <a:srgbClr val="505050"/>
+                </a:solidFill>
+              </a:rPr>
+              <a:t>leakage</a:t>
             </a:r>
             <a:r>
               <a:rPr lang="fr-FR" sz="1200" i="1" dirty="0">
                 <a:solidFill>
-                  <a:srgbClr val="646464"/>
-                </a:solidFill>
-              </a:rPr>
-              <a:t>  </a:t>
-            </a:r>
+                  <a:srgbClr val="505050"/>
+                </a:solidFill>
+              </a:rPr>
+              <a:t> en régression, jamais utilisée ailleurs</a:t>
+            </a:r>
+            <a:endParaRPr lang="fr-FR" sz="1200" i="1" dirty="0">
+              <a:solidFill>
+                <a:srgbClr val="646464"/>
+              </a:solidFill>
+            </a:endParaRPr>
           </a:p>
         </p:txBody>
       </p:sp>
@@ -10377,7 +10390,7 @@
         </p:blipFill>
         <p:spPr>
           <a:xfrm>
-            <a:off x="0" y="5446137"/>
+            <a:off x="0" y="5113197"/>
             <a:ext cx="4975815" cy="766057"/>
           </a:xfrm>
           <a:prstGeom prst="rect">
@@ -10408,7 +10421,7 @@
         </p:blipFill>
         <p:spPr>
           <a:xfrm>
-            <a:off x="4217165" y="5446137"/>
+            <a:off x="4162080" y="5146547"/>
             <a:ext cx="4395762" cy="880659"/>
           </a:xfrm>
           <a:prstGeom prst="rect">
@@ -10439,7 +10452,7 @@
         </p:blipFill>
         <p:spPr>
           <a:xfrm>
-            <a:off x="7587266" y="5376017"/>
+            <a:off x="7587266" y="5146547"/>
             <a:ext cx="3444912" cy="906296"/>
           </a:xfrm>
           <a:prstGeom prst="rect">
@@ -10522,6 +10535,92 @@
           </a:prstGeom>
         </p:spPr>
       </p:pic>
+      <p:sp>
+        <p:nvSpPr>
+          <p:cNvPr id="7" name="TextBox 8">
+            <a:extLst>
+              <a:ext uri="{FF2B5EF4-FFF2-40B4-BE49-F238E27FC236}">
+                <a16:creationId xmlns:a16="http://schemas.microsoft.com/office/drawing/2014/main" id="{56E45B2B-FE26-BE06-AA60-74581AC7EDDA}"/>
+              </a:ext>
+            </a:extLst>
+          </p:cNvPr>
+          <p:cNvSpPr txBox="1"/>
+          <p:nvPr/>
+        </p:nvSpPr>
+        <p:spPr>
+          <a:xfrm>
+            <a:off x="310895" y="6225454"/>
+            <a:ext cx="10721283" cy="276999"/>
+          </a:xfrm>
+          <a:prstGeom prst="rect">
+            <a:avLst/>
+          </a:prstGeom>
+          <a:noFill/>
+        </p:spPr>
+        <p:txBody>
+          <a:bodyPr wrap="square">
+            <a:spAutoFit/>
+          </a:bodyPr>
+          <a:lstStyle/>
+          <a:p>
+            <a:r>
+              <a:rPr lang="fr-FR" sz="1200" i="1" dirty="0" err="1">
+                <a:solidFill>
+                  <a:srgbClr val="646464"/>
+                </a:solidFill>
+              </a:rPr>
+              <a:t>Bergstra</a:t>
+            </a:r>
+            <a:r>
+              <a:rPr lang="fr-FR" sz="1200" i="1" dirty="0">
+                <a:solidFill>
+                  <a:srgbClr val="646464"/>
+                </a:solidFill>
+              </a:rPr>
+              <a:t> &amp; Bengio (2012) montrent que pour les hyperparamètres continus, l'aléatoire couvre mieux l'espace que la grille fixe. C'est un meilleur compromis coût/qualité.</a:t>
+            </a:r>
+          </a:p>
+        </p:txBody>
+      </p:sp>
+      <p:sp>
+        <p:nvSpPr>
+          <p:cNvPr id="9" name="TextBox 8">
+            <a:extLst>
+              <a:ext uri="{FF2B5EF4-FFF2-40B4-BE49-F238E27FC236}">
+                <a16:creationId xmlns:a16="http://schemas.microsoft.com/office/drawing/2014/main" id="{608C596F-9E90-AD73-2BB2-6DCC8606EB1B}"/>
+              </a:ext>
+            </a:extLst>
+          </p:cNvPr>
+          <p:cNvSpPr txBox="1"/>
+          <p:nvPr/>
+        </p:nvSpPr>
+        <p:spPr>
+          <a:xfrm>
+            <a:off x="310894" y="6477883"/>
+            <a:ext cx="10721283" cy="276999"/>
+          </a:xfrm>
+          <a:prstGeom prst="rect">
+            <a:avLst/>
+          </a:prstGeom>
+          <a:noFill/>
+        </p:spPr>
+        <p:txBody>
+          <a:bodyPr wrap="square">
+            <a:spAutoFit/>
+          </a:bodyPr>
+          <a:lstStyle/>
+          <a:p>
+            <a:r>
+              <a:rPr lang="fr-FR" sz="1200" i="1" dirty="0">
+                <a:solidFill>
+                  <a:srgbClr val="646464"/>
+                </a:solidFill>
+              </a:rPr>
+              <a:t>James et al. (2021) recommandent k=5 ou k=10 comme valeurs standard ; à cette taille d'échantillon, la différence de précision entre les deux est négligeable.</a:t>
+            </a:r>
+          </a:p>
+        </p:txBody>
+      </p:sp>
     </p:spTree>
   </p:cSld>
   <p:clrMapOvr>
@@ -10804,7 +10903,7 @@
                   <a:srgbClr val="000000"/>
                 </a:solidFill>
               </a:rPr>
-              <a:t>fixe </a:t>
+              <a:t>fixe les</a:t>
             </a:r>
             <a:r>
               <a:rPr dirty="0">
@@ -10812,7 +10911,7 @@
                   <a:srgbClr val="000000"/>
                 </a:solidFill>
               </a:rPr>
-              <a:t>16/16 coefficients </a:t>
+              <a:t> coefficients </a:t>
             </a:r>
             <a:r>
               <a:rPr lang="fr-FR" dirty="0">
@@ -14400,6 +14499,14 @@
               </a:rPr>
               <a:t>Résultats</a:t>
             </a:r>
+            <a:r>
+              <a:rPr lang="fr-FR" sz="2400" b="1" i="0" dirty="0">
+                <a:solidFill>
+                  <a:srgbClr val="00468C"/>
+                </a:solidFill>
+              </a:rPr>
+              <a:t> sur le test</a:t>
+            </a:r>
             <a:endParaRPr sz="2400" b="1" i="0" dirty="0">
               <a:solidFill>
                 <a:srgbClr val="00468C"/>
@@ -14612,7 +14719,7 @@
         </p:nvSpPr>
         <p:spPr>
           <a:xfrm>
-            <a:off x="430680" y="4353866"/>
+            <a:off x="430680" y="4120060"/>
             <a:ext cx="11438231" cy="1754326"/>
           </a:xfrm>
           <a:prstGeom prst="rect">
@@ -14659,6 +14766,131 @@
           </a:p>
           <a:p>
             <a:endParaRPr lang="fr-FR" dirty="0"/>
+          </a:p>
+        </p:txBody>
+      </p:sp>
+      <p:sp>
+        <p:nvSpPr>
+          <p:cNvPr id="8" name="TextBox 8">
+            <a:extLst>
+              <a:ext uri="{FF2B5EF4-FFF2-40B4-BE49-F238E27FC236}">
+                <a16:creationId xmlns:a16="http://schemas.microsoft.com/office/drawing/2014/main" id="{FA001B9D-9DAE-5E6F-74BA-89FE93E1BC62}"/>
+              </a:ext>
+            </a:extLst>
+          </p:cNvPr>
+          <p:cNvSpPr txBox="1"/>
+          <p:nvPr/>
+        </p:nvSpPr>
+        <p:spPr>
+          <a:xfrm>
+            <a:off x="430680" y="5982568"/>
+            <a:ext cx="10721283" cy="276999"/>
+          </a:xfrm>
+          <a:prstGeom prst="rect">
+            <a:avLst/>
+          </a:prstGeom>
+          <a:noFill/>
+        </p:spPr>
+        <p:txBody>
+          <a:bodyPr wrap="square">
+            <a:spAutoFit/>
+          </a:bodyPr>
+          <a:lstStyle/>
+          <a:p>
+            <a:r>
+              <a:rPr lang="fr-FR" sz="1200" i="1" dirty="0">
+                <a:solidFill>
+                  <a:srgbClr val="646464"/>
+                </a:solidFill>
+              </a:rPr>
+              <a:t>LR : prédit presque autant "à risque" que "sans risque" pour les deux groupes — comportement quasi-aléatoire. Elle rate 2439 vrais malades (FN).</a:t>
+            </a:r>
+          </a:p>
+        </p:txBody>
+      </p:sp>
+      <p:sp>
+        <p:nvSpPr>
+          <p:cNvPr id="10" name="TextBox 8">
+            <a:extLst>
+              <a:ext uri="{FF2B5EF4-FFF2-40B4-BE49-F238E27FC236}">
+                <a16:creationId xmlns:a16="http://schemas.microsoft.com/office/drawing/2014/main" id="{59637764-31BE-0377-BE5F-80CB09DB08A7}"/>
+              </a:ext>
+            </a:extLst>
+          </p:cNvPr>
+          <p:cNvSpPr txBox="1"/>
+          <p:nvPr/>
+        </p:nvSpPr>
+        <p:spPr>
+          <a:xfrm>
+            <a:off x="430680" y="6229249"/>
+            <a:ext cx="10721283" cy="276999"/>
+          </a:xfrm>
+          <a:prstGeom prst="rect">
+            <a:avLst/>
+          </a:prstGeom>
+          <a:noFill/>
+        </p:spPr>
+        <p:txBody>
+          <a:bodyPr wrap="square">
+            <a:spAutoFit/>
+          </a:bodyPr>
+          <a:lstStyle/>
+          <a:p>
+            <a:r>
+              <a:rPr lang="fr-FR" sz="1200" i="1" dirty="0">
+                <a:solidFill>
+                  <a:srgbClr val="646464"/>
+                </a:solidFill>
+              </a:rPr>
+              <a:t>RF : penche vers "sans risque" — elle détecte seulement 1762 malades sur 4964 réels. Le rappel est le plus faible des trois (0.355).</a:t>
+            </a:r>
+          </a:p>
+        </p:txBody>
+      </p:sp>
+      <p:sp>
+        <p:nvSpPr>
+          <p:cNvPr id="15" name="TextBox 8">
+            <a:extLst>
+              <a:ext uri="{FF2B5EF4-FFF2-40B4-BE49-F238E27FC236}">
+                <a16:creationId xmlns:a16="http://schemas.microsoft.com/office/drawing/2014/main" id="{17135B87-4B47-6E74-4ACD-09820DE80F14}"/>
+              </a:ext>
+            </a:extLst>
+          </p:cNvPr>
+          <p:cNvSpPr txBox="1"/>
+          <p:nvPr/>
+        </p:nvSpPr>
+        <p:spPr>
+          <a:xfrm>
+            <a:off x="430680" y="6475930"/>
+            <a:ext cx="10721283" cy="276999"/>
+          </a:xfrm>
+          <a:prstGeom prst="rect">
+            <a:avLst/>
+          </a:prstGeom>
+          <a:noFill/>
+        </p:spPr>
+        <p:txBody>
+          <a:bodyPr wrap="square">
+            <a:spAutoFit/>
+          </a:bodyPr>
+          <a:lstStyle/>
+          <a:p>
+            <a:r>
+              <a:rPr lang="fr-FR" sz="1200" i="1" dirty="0" err="1">
+                <a:solidFill>
+                  <a:srgbClr val="646464"/>
+                </a:solidFill>
+              </a:rPr>
+              <a:t>XGBoost</a:t>
+            </a:r>
+            <a:r>
+              <a:rPr lang="fr-FR" sz="1200" i="1" dirty="0">
+                <a:solidFill>
+                  <a:srgbClr val="646464"/>
+                </a:solidFill>
+              </a:rPr>
+              <a:t> : Meilleur rappel (0.441) — il détecte plus de malades, mais au prix de beaucoup de faux positifs (6717).</a:t>
+            </a:r>
           </a:p>
         </p:txBody>
       </p:sp>
@@ -16782,8 +17014,8 @@
         </p:blipFill>
         <p:spPr>
           <a:xfrm>
-            <a:off x="6813706" y="2050163"/>
-            <a:ext cx="4506086" cy="4361980"/>
+            <a:off x="6555037" y="1708948"/>
+            <a:ext cx="4742722" cy="4600392"/>
           </a:xfrm>
           <a:prstGeom prst="rect">
             <a:avLst/>
@@ -17132,7 +17364,7 @@
         </p:nvSpPr>
         <p:spPr>
           <a:xfrm>
-            <a:off x="6435476" y="6401644"/>
+            <a:off x="6312685" y="6381755"/>
             <a:ext cx="5262546" cy="261610"/>
           </a:xfrm>
           <a:prstGeom prst="rect">
@@ -17564,7 +17796,39 @@
                   <a:srgbClr val="000000"/>
                 </a:solidFill>
               </a:rPr>
-              <a:t> technique ne </a:t>
+              <a:t> </a:t>
+            </a:r>
+            <a:r>
+              <a:rPr lang="fr-FR" b="0" i="0" dirty="0">
+                <a:solidFill>
+                  <a:srgbClr val="000000"/>
+                </a:solidFill>
+              </a:rPr>
+              <a:t>des </a:t>
+            </a:r>
+            <a:r>
+              <a:rPr b="0" i="0" dirty="0">
+                <a:solidFill>
+                  <a:srgbClr val="000000"/>
+                </a:solidFill>
+              </a:rPr>
+              <a:t>technique</a:t>
+            </a:r>
+            <a:r>
+              <a:rPr lang="fr-FR" b="0" i="0" dirty="0">
+                <a:solidFill>
+                  <a:srgbClr val="000000"/>
+                </a:solidFill>
+              </a:rPr>
+              <a:t>s que j’ai utilisées</a:t>
+            </a:r>
+            <a:r>
+              <a:rPr b="0" i="0" dirty="0">
+                <a:solidFill>
+                  <a:srgbClr val="000000"/>
+                </a:solidFill>
+              </a:rPr>
+              <a:t> ne </a:t>
             </a:r>
             <a:r>
               <a:rPr b="0" i="0" dirty="0" err="1">
@@ -17756,7 +18020,7 @@
                   <a:srgbClr val="000000"/>
                 </a:solidFill>
               </a:rPr>
-              <a:t>Lasso : 16/16 coefficients = 0</a:t>
+              <a:t>Lasso : coefficients = 0</a:t>
             </a:r>
             <a:endParaRPr lang="fr-FR" dirty="0">
               <a:solidFill>

</xml_diff>

<commit_message>
Mise à jour support de présentation (PDF + PPTX)
Co-Authored-By: Claude Sonnet 4.6 <noreply@anthropic.com>
</commit_message>
<xml_diff>
--- a/Support Mahamat - Memoire.pptx
+++ b/Support Mahamat - Memoire.pptx
@@ -10230,7 +10230,7 @@
         <p:spPr>
           <a:xfrm>
             <a:off x="320040" y="2453136"/>
-            <a:ext cx="11228832" cy="923330"/>
+            <a:ext cx="11228832" cy="646331"/>
           </a:xfrm>
           <a:prstGeom prst="rect">
             <a:avLst/>
@@ -10270,99 +10270,28 @@
           </a:p>
           <a:p>
             <a:r>
-              <a:rPr dirty="0" err="1">
+              <a:rPr lang="fr-FR" dirty="0">
                 <a:solidFill>
                   <a:srgbClr val="000000"/>
                 </a:solidFill>
               </a:rPr>
-              <a:t>Exclue</a:t>
-            </a:r>
-            <a:r>
-              <a:rPr dirty="0">
+              <a:t>R² artificiel = 0.675 avec </a:t>
+            </a:r>
+            <a:r>
+              <a:rPr lang="fr-FR" dirty="0" err="1">
                 <a:solidFill>
                   <a:srgbClr val="000000"/>
                 </a:solidFill>
               </a:rPr>
-              <a:t> de la </a:t>
-            </a:r>
-            <a:r>
-              <a:rPr dirty="0" err="1">
+              <a:t>leakage</a:t>
+            </a:r>
+            <a:r>
+              <a:rPr lang="fr-FR" dirty="0">
                 <a:solidFill>
                   <a:srgbClr val="000000"/>
                 </a:solidFill>
               </a:rPr>
-              <a:t>régression</a:t>
-            </a:r>
-            <a:r>
-              <a:rPr dirty="0">
-                <a:solidFill>
-                  <a:srgbClr val="000000"/>
-                </a:solidFill>
-              </a:rPr>
-              <a:t>, </a:t>
-            </a:r>
-            <a:r>
-              <a:rPr dirty="0" err="1">
-                <a:solidFill>
-                  <a:srgbClr val="000000"/>
-                </a:solidFill>
-              </a:rPr>
-              <a:t>conservée</a:t>
-            </a:r>
-            <a:r>
-              <a:rPr dirty="0">
-                <a:solidFill>
-                  <a:srgbClr val="000000"/>
-                </a:solidFill>
-              </a:rPr>
-              <a:t> </a:t>
-            </a:r>
-            <a:r>
-              <a:rPr dirty="0" err="1">
-                <a:solidFill>
-                  <a:srgbClr val="000000"/>
-                </a:solidFill>
-              </a:rPr>
-              <a:t>uniquement</a:t>
-            </a:r>
-            <a:r>
-              <a:rPr dirty="0">
-                <a:solidFill>
-                  <a:srgbClr val="000000"/>
-                </a:solidFill>
-              </a:rPr>
-              <a:t> pour le clustering</a:t>
-            </a:r>
-            <a:endParaRPr lang="fr-FR" dirty="0">
-              <a:solidFill>
-                <a:srgbClr val="000000"/>
-              </a:solidFill>
-            </a:endParaRPr>
-          </a:p>
-          <a:p>
-            <a:r>
-              <a:rPr lang="fr-FR" dirty="0">
-                <a:solidFill>
-                  <a:srgbClr val="000000"/>
-                </a:solidFill>
-              </a:rPr>
-              <a:t>R² artificiel = 0.675 avec </a:t>
-            </a:r>
-            <a:r>
-              <a:rPr lang="fr-FR" dirty="0" err="1">
-                <a:solidFill>
-                  <a:srgbClr val="000000"/>
-                </a:solidFill>
-              </a:rPr>
-              <a:t>leakage</a:t>
-            </a:r>
-            <a:r>
-              <a:rPr lang="fr-FR" dirty="0">
-                <a:solidFill>
-                  <a:srgbClr val="000000"/>
-                </a:solidFill>
-              </a:rPr>
-              <a:t> → R² ≈ 0 après suppression</a:t>
+              <a:t> → R² ≈ 0 après suppression (exclue de la régression)</a:t>
             </a:r>
           </a:p>
         </p:txBody>

</xml_diff>